<commit_message>
Remove generated callout overlays from presentation screenshots
Keep the 30 slides and new screenshots (full allocation balance cards,
request-type approval-cycles form, Arabic RTL dark mode) without the
drawn highlight boxes so annotations can be placed manually in Impress.

Generated with [Devin](https://devin.ai)

Co-Authored-By: Devin <158243242+devin-ai-integration[bot]@users.noreply.github.com>
</commit_message>
<xml_diff>
--- a/docs/presentation/Daimoma-presentation.pptx
+++ b/docs/presentation/Daimoma-presentation.pptx
@@ -394,7 +394,7 @@
             <a:pPr indent="0" algn="r">
               <a:buNone/>
             </a:pPr>
-            <a:fld id="{C6A289D4-36F6-4EB2-9F70-3CE7FCE14FF0}" type="slidenum">
+            <a:fld id="{ED787327-9879-41EB-A44F-BD2CDC38FD64}" type="slidenum">
               <a:rPr lang="en-US" sz="1400" b="0" u="none" strike="noStrike">
                 <a:solidFill>
                   <a:srgbClr val="000000"/>
@@ -441,7 +441,7 @@
       </p:grpSpPr>
       <p:sp>
         <p:nvSpPr>
-          <p:cNvPr id="226" name=""/>
+          <p:cNvPr id="202" name=""/>
           <p:cNvSpPr txBox="1"/>
           <p:nvPr/>
         </p:nvSpPr>
@@ -568,7 +568,7 @@
       </p:grpSpPr>
       <p:sp>
         <p:nvSpPr>
-          <p:cNvPr id="235" name=""/>
+          <p:cNvPr id="211" name=""/>
           <p:cNvSpPr txBox="1"/>
           <p:nvPr/>
         </p:nvSpPr>
@@ -640,7 +640,7 @@
       </p:grpSpPr>
       <p:sp>
         <p:nvSpPr>
-          <p:cNvPr id="236" name=""/>
+          <p:cNvPr id="212" name=""/>
           <p:cNvSpPr txBox="1"/>
           <p:nvPr/>
         </p:nvSpPr>
@@ -712,7 +712,7 @@
       </p:grpSpPr>
       <p:sp>
         <p:nvSpPr>
-          <p:cNvPr id="237" name=""/>
+          <p:cNvPr id="213" name=""/>
           <p:cNvSpPr txBox="1"/>
           <p:nvPr/>
         </p:nvSpPr>
@@ -784,7 +784,7 @@
       </p:grpSpPr>
       <p:sp>
         <p:nvSpPr>
-          <p:cNvPr id="238" name=""/>
+          <p:cNvPr id="214" name=""/>
           <p:cNvSpPr txBox="1"/>
           <p:nvPr/>
         </p:nvSpPr>
@@ -856,7 +856,7 @@
       </p:grpSpPr>
       <p:sp>
         <p:nvSpPr>
-          <p:cNvPr id="239" name=""/>
+          <p:cNvPr id="215" name=""/>
           <p:cNvSpPr txBox="1"/>
           <p:nvPr/>
         </p:nvSpPr>
@@ -928,7 +928,7 @@
       </p:grpSpPr>
       <p:sp>
         <p:nvSpPr>
-          <p:cNvPr id="240" name=""/>
+          <p:cNvPr id="216" name=""/>
           <p:cNvSpPr txBox="1"/>
           <p:nvPr/>
         </p:nvSpPr>
@@ -1000,7 +1000,7 @@
       </p:grpSpPr>
       <p:sp>
         <p:nvSpPr>
-          <p:cNvPr id="241" name=""/>
+          <p:cNvPr id="217" name=""/>
           <p:cNvSpPr txBox="1"/>
           <p:nvPr/>
         </p:nvSpPr>
@@ -1072,7 +1072,7 @@
       </p:grpSpPr>
       <p:sp>
         <p:nvSpPr>
-          <p:cNvPr id="242" name=""/>
+          <p:cNvPr id="218" name=""/>
           <p:cNvSpPr txBox="1"/>
           <p:nvPr/>
         </p:nvSpPr>
@@ -1144,7 +1144,7 @@
       </p:grpSpPr>
       <p:sp>
         <p:nvSpPr>
-          <p:cNvPr id="243" name=""/>
+          <p:cNvPr id="219" name=""/>
           <p:cNvSpPr txBox="1"/>
           <p:nvPr/>
         </p:nvSpPr>
@@ -1216,7 +1216,7 @@
       </p:grpSpPr>
       <p:sp>
         <p:nvSpPr>
-          <p:cNvPr id="244" name=""/>
+          <p:cNvPr id="220" name=""/>
           <p:cNvSpPr txBox="1"/>
           <p:nvPr/>
         </p:nvSpPr>
@@ -1288,7 +1288,7 @@
       </p:grpSpPr>
       <p:sp>
         <p:nvSpPr>
-          <p:cNvPr id="227" name=""/>
+          <p:cNvPr id="203" name=""/>
           <p:cNvSpPr txBox="1"/>
           <p:nvPr/>
         </p:nvSpPr>
@@ -1360,7 +1360,7 @@
       </p:grpSpPr>
       <p:sp>
         <p:nvSpPr>
-          <p:cNvPr id="245" name=""/>
+          <p:cNvPr id="221" name=""/>
           <p:cNvSpPr txBox="1"/>
           <p:nvPr/>
         </p:nvSpPr>
@@ -1432,7 +1432,7 @@
       </p:grpSpPr>
       <p:sp>
         <p:nvSpPr>
-          <p:cNvPr id="246" name=""/>
+          <p:cNvPr id="222" name=""/>
           <p:cNvSpPr txBox="1"/>
           <p:nvPr/>
         </p:nvSpPr>
@@ -1504,7 +1504,7 @@
       </p:grpSpPr>
       <p:sp>
         <p:nvSpPr>
-          <p:cNvPr id="247" name=""/>
+          <p:cNvPr id="223" name=""/>
           <p:cNvSpPr txBox="1"/>
           <p:nvPr/>
         </p:nvSpPr>
@@ -1576,7 +1576,7 @@
       </p:grpSpPr>
       <p:sp>
         <p:nvSpPr>
-          <p:cNvPr id="248" name=""/>
+          <p:cNvPr id="224" name=""/>
           <p:cNvSpPr txBox="1"/>
           <p:nvPr/>
         </p:nvSpPr>
@@ -1648,7 +1648,7 @@
       </p:grpSpPr>
       <p:sp>
         <p:nvSpPr>
-          <p:cNvPr id="249" name=""/>
+          <p:cNvPr id="225" name=""/>
           <p:cNvSpPr txBox="1"/>
           <p:nvPr/>
         </p:nvSpPr>
@@ -1720,7 +1720,7 @@
       </p:grpSpPr>
       <p:sp>
         <p:nvSpPr>
-          <p:cNvPr id="250" name=""/>
+          <p:cNvPr id="226" name=""/>
           <p:cNvSpPr txBox="1"/>
           <p:nvPr/>
         </p:nvSpPr>
@@ -1792,7 +1792,7 @@
       </p:grpSpPr>
       <p:sp>
         <p:nvSpPr>
-          <p:cNvPr id="251" name=""/>
+          <p:cNvPr id="227" name=""/>
           <p:cNvSpPr txBox="1"/>
           <p:nvPr/>
         </p:nvSpPr>
@@ -1864,7 +1864,7 @@
       </p:grpSpPr>
       <p:sp>
         <p:nvSpPr>
-          <p:cNvPr id="228" name=""/>
+          <p:cNvPr id="204" name=""/>
           <p:cNvSpPr txBox="1"/>
           <p:nvPr/>
         </p:nvSpPr>
@@ -1936,7 +1936,7 @@
       </p:grpSpPr>
       <p:sp>
         <p:nvSpPr>
-          <p:cNvPr id="252" name=""/>
+          <p:cNvPr id="228" name=""/>
           <p:cNvSpPr txBox="1"/>
           <p:nvPr/>
         </p:nvSpPr>
@@ -2008,7 +2008,7 @@
       </p:grpSpPr>
       <p:sp>
         <p:nvSpPr>
-          <p:cNvPr id="229" name=""/>
+          <p:cNvPr id="205" name=""/>
           <p:cNvSpPr txBox="1"/>
           <p:nvPr/>
         </p:nvSpPr>
@@ -2080,7 +2080,7 @@
       </p:grpSpPr>
       <p:sp>
         <p:nvSpPr>
-          <p:cNvPr id="230" name=""/>
+          <p:cNvPr id="206" name=""/>
           <p:cNvSpPr txBox="1"/>
           <p:nvPr/>
         </p:nvSpPr>
@@ -2174,7 +2174,7 @@
       </p:grpSpPr>
       <p:sp>
         <p:nvSpPr>
-          <p:cNvPr id="231" name=""/>
+          <p:cNvPr id="207" name=""/>
           <p:cNvSpPr txBox="1"/>
           <p:nvPr/>
         </p:nvSpPr>
@@ -2246,7 +2246,7 @@
       </p:grpSpPr>
       <p:sp>
         <p:nvSpPr>
-          <p:cNvPr id="232" name=""/>
+          <p:cNvPr id="208" name=""/>
           <p:cNvSpPr txBox="1"/>
           <p:nvPr/>
         </p:nvSpPr>
@@ -2318,7 +2318,7 @@
       </p:grpSpPr>
       <p:sp>
         <p:nvSpPr>
-          <p:cNvPr id="233" name=""/>
+          <p:cNvPr id="209" name=""/>
           <p:cNvSpPr txBox="1"/>
           <p:nvPr/>
         </p:nvSpPr>
@@ -2390,7 +2390,7 @@
       </p:grpSpPr>
       <p:sp>
         <p:nvSpPr>
-          <p:cNvPr id="234" name=""/>
+          <p:cNvPr id="210" name=""/>
           <p:cNvSpPr txBox="1"/>
           <p:nvPr/>
         </p:nvSpPr>
@@ -2494,7 +2494,7 @@
         <p:txBody>
           <a:bodyPr/>
           <a:p>
-            <a:fld id="{023B95B2-35E7-4269-9A68-C5C144E8F3AA}" type="slidenum">
+            <a:fld id="{BB9C5344-D35A-44E0-9D1B-632EE588BE33}" type="slidenum">
               <a:t>&lt;#&gt;</a:t>
             </a:fld>
           </a:p>
@@ -2661,7 +2661,7 @@
         <p:txBody>
           <a:bodyPr/>
           <a:p>
-            <a:fld id="{7D54715A-6DC5-49C8-8F3C-1536B370A85C}" type="slidenum">
+            <a:fld id="{9871163A-1FBE-4C37-A326-9C2CABA1B014}" type="slidenum">
               <a:t>&lt;#&gt;</a:t>
             </a:fld>
           </a:p>
@@ -3340,7 +3340,7 @@
             <a:pPr indent="0" algn="r">
               <a:buNone/>
             </a:pPr>
-            <a:fld id="{6E162645-1998-41F6-B8DF-328750413AC1}" type="slidenum">
+            <a:fld id="{3517EF3A-4620-40FE-8767-3EB628EE0922}" type="slidenum">
               <a:rPr lang="en-US" sz="1400" b="0" u="none" strike="noStrike">
                 <a:solidFill>
                   <a:srgbClr val="000000"/>
@@ -3709,7 +3709,7 @@
       </p:grpSpPr>
       <p:sp>
         <p:nvSpPr>
-          <p:cNvPr id="81" name=""/>
+          <p:cNvPr id="71" name=""/>
           <p:cNvSpPr txBox="1"/>
           <p:nvPr/>
         </p:nvSpPr>
@@ -3755,7 +3755,7 @@
       </p:sp>
       <p:sp>
         <p:nvSpPr>
-          <p:cNvPr id="82" name=""/>
+          <p:cNvPr id="72" name=""/>
           <p:cNvSpPr txBox="1"/>
           <p:nvPr/>
         </p:nvSpPr>
@@ -3792,7 +3792,7 @@
       </p:sp>
       <p:pic>
         <p:nvPicPr>
-          <p:cNvPr id="83" name=""/>
+          <p:cNvPr id="73" name=""/>
           <p:cNvPicPr/>
           <p:nvPr/>
         </p:nvPicPr>
@@ -3816,7 +3816,7 @@
       </p:pic>
       <p:sp>
         <p:nvSpPr>
-          <p:cNvPr id="84" name=""/>
+          <p:cNvPr id="74" name=""/>
           <p:cNvSpPr txBox="1"/>
           <p:nvPr/>
         </p:nvSpPr>
@@ -3899,7 +3899,7 @@
       </p:grpSpPr>
       <p:sp>
         <p:nvSpPr>
-          <p:cNvPr id="85" name=""/>
+          <p:cNvPr id="75" name=""/>
           <p:cNvSpPr txBox="1"/>
           <p:nvPr/>
         </p:nvSpPr>
@@ -3945,7 +3945,7 @@
       </p:sp>
       <p:sp>
         <p:nvSpPr>
-          <p:cNvPr id="86" name=""/>
+          <p:cNvPr id="76" name=""/>
           <p:cNvSpPr txBox="1"/>
           <p:nvPr/>
         </p:nvSpPr>
@@ -3982,7 +3982,7 @@
       </p:sp>
       <p:sp>
         <p:nvSpPr>
-          <p:cNvPr id="87" name=""/>
+          <p:cNvPr id="77" name=""/>
           <p:cNvSpPr txBox="1"/>
           <p:nvPr/>
         </p:nvSpPr>
@@ -4019,7 +4019,7 @@
       </p:sp>
       <p:sp>
         <p:nvSpPr>
-          <p:cNvPr id="88" name=""/>
+          <p:cNvPr id="78" name=""/>
           <p:cNvSpPr txBox="1"/>
           <p:nvPr/>
         </p:nvSpPr>
@@ -4070,7 +4070,7 @@
       </p:sp>
       <p:sp>
         <p:nvSpPr>
-          <p:cNvPr id="89" name=""/>
+          <p:cNvPr id="79" name=""/>
           <p:cNvSpPr txBox="1"/>
           <p:nvPr/>
         </p:nvSpPr>
@@ -4107,7 +4107,7 @@
       </p:sp>
       <p:sp>
         <p:nvSpPr>
-          <p:cNvPr id="90" name=""/>
+          <p:cNvPr id="80" name=""/>
           <p:cNvSpPr txBox="1"/>
           <p:nvPr/>
         </p:nvSpPr>
@@ -4158,7 +4158,7 @@
       </p:sp>
       <p:sp>
         <p:nvSpPr>
-          <p:cNvPr id="91" name=""/>
+          <p:cNvPr id="81" name=""/>
           <p:cNvSpPr txBox="1"/>
           <p:nvPr/>
         </p:nvSpPr>
@@ -4195,7 +4195,7 @@
       </p:sp>
       <p:sp>
         <p:nvSpPr>
-          <p:cNvPr id="92" name=""/>
+          <p:cNvPr id="82" name=""/>
           <p:cNvSpPr txBox="1"/>
           <p:nvPr/>
         </p:nvSpPr>
@@ -4246,7 +4246,7 @@
       </p:sp>
       <p:sp>
         <p:nvSpPr>
-          <p:cNvPr id="93" name=""/>
+          <p:cNvPr id="83" name=""/>
           <p:cNvSpPr txBox="1"/>
           <p:nvPr/>
         </p:nvSpPr>
@@ -4283,7 +4283,7 @@
       </p:sp>
       <p:sp>
         <p:nvSpPr>
-          <p:cNvPr id="94" name=""/>
+          <p:cNvPr id="84" name=""/>
           <p:cNvSpPr txBox="1"/>
           <p:nvPr/>
         </p:nvSpPr>
@@ -4371,7 +4371,7 @@
       </p:grpSpPr>
       <p:sp>
         <p:nvSpPr>
-          <p:cNvPr id="95" name=""/>
+          <p:cNvPr id="85" name=""/>
           <p:cNvSpPr txBox="1"/>
           <p:nvPr/>
         </p:nvSpPr>
@@ -4417,7 +4417,7 @@
       </p:sp>
       <p:sp>
         <p:nvSpPr>
-          <p:cNvPr id="96" name=""/>
+          <p:cNvPr id="86" name=""/>
           <p:cNvSpPr txBox="1"/>
           <p:nvPr/>
         </p:nvSpPr>
@@ -4454,7 +4454,7 @@
       </p:sp>
       <p:pic>
         <p:nvPicPr>
-          <p:cNvPr id="97" name=""/>
+          <p:cNvPr id="87" name=""/>
           <p:cNvPicPr/>
           <p:nvPr/>
         </p:nvPicPr>
@@ -4478,7 +4478,7 @@
       </p:pic>
       <p:sp>
         <p:nvSpPr>
-          <p:cNvPr id="98" name=""/>
+          <p:cNvPr id="88" name=""/>
           <p:cNvSpPr txBox="1"/>
           <p:nvPr/>
         </p:nvSpPr>
@@ -4561,7 +4561,7 @@
       </p:grpSpPr>
       <p:sp>
         <p:nvSpPr>
-          <p:cNvPr id="99" name=""/>
+          <p:cNvPr id="89" name=""/>
           <p:cNvSpPr txBox="1"/>
           <p:nvPr/>
         </p:nvSpPr>
@@ -4607,7 +4607,7 @@
       </p:sp>
       <p:sp>
         <p:nvSpPr>
-          <p:cNvPr id="100" name=""/>
+          <p:cNvPr id="90" name=""/>
           <p:cNvSpPr txBox="1"/>
           <p:nvPr/>
         </p:nvSpPr>
@@ -4644,7 +4644,7 @@
       </p:sp>
       <p:sp>
         <p:nvSpPr>
-          <p:cNvPr id="101" name=""/>
+          <p:cNvPr id="91" name=""/>
           <p:cNvSpPr txBox="1"/>
           <p:nvPr/>
         </p:nvSpPr>
@@ -4681,7 +4681,7 @@
       </p:sp>
       <p:sp>
         <p:nvSpPr>
-          <p:cNvPr id="102" name=""/>
+          <p:cNvPr id="92" name=""/>
           <p:cNvSpPr txBox="1"/>
           <p:nvPr/>
         </p:nvSpPr>
@@ -4732,7 +4732,7 @@
       </p:sp>
       <p:sp>
         <p:nvSpPr>
-          <p:cNvPr id="103" name=""/>
+          <p:cNvPr id="93" name=""/>
           <p:cNvSpPr txBox="1"/>
           <p:nvPr/>
         </p:nvSpPr>
@@ -4769,7 +4769,7 @@
       </p:sp>
       <p:sp>
         <p:nvSpPr>
-          <p:cNvPr id="104" name=""/>
+          <p:cNvPr id="94" name=""/>
           <p:cNvSpPr txBox="1"/>
           <p:nvPr/>
         </p:nvSpPr>
@@ -4820,7 +4820,7 @@
       </p:sp>
       <p:sp>
         <p:nvSpPr>
-          <p:cNvPr id="105" name=""/>
+          <p:cNvPr id="95" name=""/>
           <p:cNvSpPr txBox="1"/>
           <p:nvPr/>
         </p:nvSpPr>
@@ -4857,7 +4857,7 @@
       </p:sp>
       <p:sp>
         <p:nvSpPr>
-          <p:cNvPr id="106" name=""/>
+          <p:cNvPr id="96" name=""/>
           <p:cNvSpPr txBox="1"/>
           <p:nvPr/>
         </p:nvSpPr>
@@ -4908,7 +4908,7 @@
       </p:sp>
       <p:sp>
         <p:nvSpPr>
-          <p:cNvPr id="107" name=""/>
+          <p:cNvPr id="97" name=""/>
           <p:cNvSpPr txBox="1"/>
           <p:nvPr/>
         </p:nvSpPr>
@@ -4945,7 +4945,7 @@
       </p:sp>
       <p:sp>
         <p:nvSpPr>
-          <p:cNvPr id="108" name=""/>
+          <p:cNvPr id="98" name=""/>
           <p:cNvSpPr txBox="1"/>
           <p:nvPr/>
         </p:nvSpPr>
@@ -4996,7 +4996,7 @@
       </p:sp>
       <p:sp>
         <p:nvSpPr>
-          <p:cNvPr id="109" name=""/>
+          <p:cNvPr id="99" name=""/>
           <p:cNvSpPr txBox="1"/>
           <p:nvPr/>
         </p:nvSpPr>
@@ -5033,7 +5033,7 @@
       </p:sp>
       <p:sp>
         <p:nvSpPr>
-          <p:cNvPr id="110" name=""/>
+          <p:cNvPr id="100" name=""/>
           <p:cNvSpPr txBox="1"/>
           <p:nvPr/>
         </p:nvSpPr>
@@ -5121,7 +5121,7 @@
       </p:grpSpPr>
       <p:sp>
         <p:nvSpPr>
-          <p:cNvPr id="111" name=""/>
+          <p:cNvPr id="101" name=""/>
           <p:cNvSpPr txBox="1"/>
           <p:nvPr/>
         </p:nvSpPr>
@@ -5167,7 +5167,7 @@
       </p:sp>
       <p:sp>
         <p:nvSpPr>
-          <p:cNvPr id="112" name=""/>
+          <p:cNvPr id="102" name=""/>
           <p:cNvSpPr txBox="1"/>
           <p:nvPr/>
         </p:nvSpPr>
@@ -5204,7 +5204,7 @@
       </p:sp>
       <p:pic>
         <p:nvPicPr>
-          <p:cNvPr id="113" name=""/>
+          <p:cNvPr id="103" name=""/>
           <p:cNvPicPr/>
           <p:nvPr/>
         </p:nvPicPr>
@@ -5228,96 +5228,7 @@
       </p:pic>
       <p:sp>
         <p:nvSpPr>
-          <p:cNvPr id="114" name=""/>
-          <p:cNvSpPr txBox="1"/>
-          <p:nvPr/>
-        </p:nvSpPr>
-        <p:spPr>
-          <a:xfrm>
-            <a:off x="3040200" y="2782080"/>
-            <a:ext cx="4967280" cy="1935360"/>
-          </a:xfrm>
-          <a:prstGeom prst="rect">
-            <a:avLst/>
-          </a:prstGeom>
-          <a:noFill/>
-          <a:ln w="28800">
-            <a:solidFill>
-              <a:srgbClr val="D97706"/>
-            </a:solidFill>
-            <a:round/>
-          </a:ln>
-        </p:spPr>
-        <p:txBody>
-          <a:bodyPr lIns="104400" tIns="59400" rIns="104400" bIns="59400" anchor="t">
-            <a:spAutoFit/>
-          </a:bodyPr>
-          <a:p>
-            <a:endParaRPr lang="en-US" sz="1800" b="0" u="none" strike="noStrike">
-              <a:solidFill>
-                <a:srgbClr val="000000"/>
-              </a:solidFill>
-              <a:effectLst/>
-              <a:uFillTx/>
-              <a:latin typeface="Arial"/>
-            </a:endParaRPr>
-          </a:p>
-        </p:txBody>
-      </p:sp>
-      <p:sp>
-        <p:nvSpPr>
-          <p:cNvPr id="115" name=""/>
-          <p:cNvSpPr txBox="1"/>
-          <p:nvPr/>
-        </p:nvSpPr>
-        <p:spPr>
-          <a:xfrm>
-            <a:off x="3040200" y="2558880"/>
-            <a:ext cx="3362400" cy="201600"/>
-          </a:xfrm>
-          <a:prstGeom prst="rect">
-            <a:avLst/>
-          </a:prstGeom>
-          <a:solidFill>
-            <a:srgbClr val="103E3A"/>
-          </a:solidFill>
-          <a:ln w="14400">
-            <a:solidFill>
-              <a:srgbClr val="E6BF71"/>
-            </a:solidFill>
-            <a:round/>
-          </a:ln>
-        </p:spPr>
-        <p:txBody>
-          <a:bodyPr lIns="79200" tIns="28800" rIns="79200" bIns="28800" anchor="t">
-            <a:spAutoFit/>
-          </a:bodyPr>
-          <a:p>
-            <a:r>
-              <a:rPr lang="en-US" sz="950" b="1" u="none" strike="noStrike">
-                <a:solidFill>
-                  <a:srgbClr val="FFFFFF"/>
-                </a:solidFill>
-                <a:effectLst/>
-                <a:uFillTx/>
-                <a:latin typeface="Arial"/>
-              </a:rPr>
-              <a:t>Compact 7-day table — entries &amp; actions inline</a:t>
-            </a:r>
-            <a:endParaRPr lang="en-US" sz="950" b="0" u="none" strike="noStrike">
-              <a:solidFill>
-                <a:srgbClr val="FFFFFF"/>
-              </a:solidFill>
-              <a:effectLst/>
-              <a:uFillTx/>
-              <a:latin typeface="Arial"/>
-            </a:endParaRPr>
-          </a:p>
-        </p:txBody>
-      </p:sp>
-      <p:sp>
-        <p:nvSpPr>
-          <p:cNvPr id="116" name=""/>
+          <p:cNvPr id="104" name=""/>
           <p:cNvSpPr txBox="1"/>
           <p:nvPr/>
         </p:nvSpPr>
@@ -5400,7 +5311,7 @@
       </p:grpSpPr>
       <p:sp>
         <p:nvSpPr>
-          <p:cNvPr id="117" name=""/>
+          <p:cNvPr id="105" name=""/>
           <p:cNvSpPr txBox="1"/>
           <p:nvPr/>
         </p:nvSpPr>
@@ -5446,7 +5357,7 @@
       </p:sp>
       <p:sp>
         <p:nvSpPr>
-          <p:cNvPr id="118" name=""/>
+          <p:cNvPr id="106" name=""/>
           <p:cNvSpPr txBox="1"/>
           <p:nvPr/>
         </p:nvSpPr>
@@ -5483,7 +5394,7 @@
       </p:sp>
       <p:pic>
         <p:nvPicPr>
-          <p:cNvPr id="119" name=""/>
+          <p:cNvPr id="107" name=""/>
           <p:cNvPicPr/>
           <p:nvPr/>
         </p:nvPicPr>
@@ -5507,185 +5418,7 @@
       </p:pic>
       <p:sp>
         <p:nvSpPr>
-          <p:cNvPr id="120" name=""/>
-          <p:cNvSpPr txBox="1"/>
-          <p:nvPr/>
-        </p:nvSpPr>
-        <p:spPr>
-          <a:xfrm>
-            <a:off x="6781680" y="1088640"/>
-            <a:ext cx="1354680" cy="322560"/>
-          </a:xfrm>
-          <a:prstGeom prst="rect">
-            <a:avLst/>
-          </a:prstGeom>
-          <a:noFill/>
-          <a:ln w="28800">
-            <a:solidFill>
-              <a:srgbClr val="D97706"/>
-            </a:solidFill>
-            <a:round/>
-          </a:ln>
-        </p:spPr>
-        <p:txBody>
-          <a:bodyPr lIns="104400" tIns="59400" rIns="104400" bIns="59400" anchor="t">
-            <a:spAutoFit/>
-          </a:bodyPr>
-          <a:p>
-            <a:endParaRPr lang="en-US" sz="1800" b="0" u="none" strike="noStrike">
-              <a:solidFill>
-                <a:srgbClr val="000000"/>
-              </a:solidFill>
-              <a:effectLst/>
-              <a:uFillTx/>
-              <a:latin typeface="Arial"/>
-            </a:endParaRPr>
-          </a:p>
-        </p:txBody>
-      </p:sp>
-      <p:sp>
-        <p:nvSpPr>
-          <p:cNvPr id="121" name=""/>
-          <p:cNvSpPr txBox="1"/>
-          <p:nvPr/>
-        </p:nvSpPr>
-        <p:spPr>
-          <a:xfrm>
-            <a:off x="6781680" y="1440000"/>
-            <a:ext cx="3020400" cy="201600"/>
-          </a:xfrm>
-          <a:prstGeom prst="rect">
-            <a:avLst/>
-          </a:prstGeom>
-          <a:solidFill>
-            <a:srgbClr val="103E3A"/>
-          </a:solidFill>
-          <a:ln w="14400">
-            <a:solidFill>
-              <a:srgbClr val="E6BF71"/>
-            </a:solidFill>
-            <a:round/>
-          </a:ln>
-        </p:spPr>
-        <p:txBody>
-          <a:bodyPr lIns="79200" tIns="28800" rIns="79200" bIns="28800" anchor="t">
-            <a:spAutoFit/>
-          </a:bodyPr>
-          <a:p>
-            <a:r>
-              <a:rPr lang="en-US" sz="950" b="1" u="none" strike="noStrike">
-                <a:solidFill>
-                  <a:srgbClr val="FFFFFF"/>
-                </a:solidFill>
-                <a:effectLst/>
-                <a:uFillTx/>
-                <a:latin typeface="Arial"/>
-              </a:rPr>
-              <a:t>Check-in punch · EN/AR · Dark mode · Bell</a:t>
-            </a:r>
-            <a:endParaRPr lang="en-US" sz="950" b="0" u="none" strike="noStrike">
-              <a:solidFill>
-                <a:srgbClr val="FFFFFF"/>
-              </a:solidFill>
-              <a:effectLst/>
-              <a:uFillTx/>
-              <a:latin typeface="Arial"/>
-            </a:endParaRPr>
-          </a:p>
-        </p:txBody>
-      </p:sp>
-      <p:sp>
-        <p:nvSpPr>
-          <p:cNvPr id="122" name=""/>
-          <p:cNvSpPr txBox="1"/>
-          <p:nvPr/>
-        </p:nvSpPr>
-        <p:spPr>
-          <a:xfrm>
-            <a:off x="3104640" y="3507840"/>
-            <a:ext cx="3354480" cy="1370880"/>
-          </a:xfrm>
-          <a:prstGeom prst="rect">
-            <a:avLst/>
-          </a:prstGeom>
-          <a:noFill/>
-          <a:ln w="28800">
-            <a:solidFill>
-              <a:srgbClr val="D97706"/>
-            </a:solidFill>
-            <a:round/>
-          </a:ln>
-        </p:spPr>
-        <p:txBody>
-          <a:bodyPr lIns="104400" tIns="59400" rIns="104400" bIns="59400" anchor="t">
-            <a:spAutoFit/>
-          </a:bodyPr>
-          <a:p>
-            <a:endParaRPr lang="en-US" sz="1800" b="0" u="none" strike="noStrike">
-              <a:solidFill>
-                <a:srgbClr val="000000"/>
-              </a:solidFill>
-              <a:effectLst/>
-              <a:uFillTx/>
-              <a:latin typeface="Arial"/>
-            </a:endParaRPr>
-          </a:p>
-        </p:txBody>
-      </p:sp>
-      <p:sp>
-        <p:nvSpPr>
-          <p:cNvPr id="123" name=""/>
-          <p:cNvSpPr txBox="1"/>
-          <p:nvPr/>
-        </p:nvSpPr>
-        <p:spPr>
-          <a:xfrm>
-            <a:off x="3104640" y="3284640"/>
-            <a:ext cx="3020400" cy="201600"/>
-          </a:xfrm>
-          <a:prstGeom prst="rect">
-            <a:avLst/>
-          </a:prstGeom>
-          <a:solidFill>
-            <a:srgbClr val="103E3A"/>
-          </a:solidFill>
-          <a:ln w="14400">
-            <a:solidFill>
-              <a:srgbClr val="E6BF71"/>
-            </a:solidFill>
-            <a:round/>
-          </a:ln>
-        </p:spPr>
-        <p:txBody>
-          <a:bodyPr lIns="79200" tIns="28800" rIns="79200" bIns="28800" anchor="t">
-            <a:spAutoFit/>
-          </a:bodyPr>
-          <a:p>
-            <a:r>
-              <a:rPr lang="en-US" sz="950" b="1" u="none" strike="noStrike">
-                <a:solidFill>
-                  <a:srgbClr val="FFFFFF"/>
-                </a:solidFill>
-                <a:effectLst/>
-                <a:uFillTx/>
-                <a:latin typeface="Arial"/>
-              </a:rPr>
-              <a:t>Personal allocation balances (full cards)</a:t>
-            </a:r>
-            <a:endParaRPr lang="en-US" sz="950" b="0" u="none" strike="noStrike">
-              <a:solidFill>
-                <a:srgbClr val="FFFFFF"/>
-              </a:solidFill>
-              <a:effectLst/>
-              <a:uFillTx/>
-              <a:latin typeface="Arial"/>
-            </a:endParaRPr>
-          </a:p>
-        </p:txBody>
-      </p:sp>
-      <p:sp>
-        <p:nvSpPr>
-          <p:cNvPr id="124" name=""/>
+          <p:cNvPr id="108" name=""/>
           <p:cNvSpPr txBox="1"/>
           <p:nvPr/>
         </p:nvSpPr>
@@ -5768,7 +5501,7 @@
       </p:grpSpPr>
       <p:sp>
         <p:nvSpPr>
-          <p:cNvPr id="125" name=""/>
+          <p:cNvPr id="109" name=""/>
           <p:cNvSpPr txBox="1"/>
           <p:nvPr/>
         </p:nvSpPr>
@@ -5814,7 +5547,7 @@
       </p:sp>
       <p:sp>
         <p:nvSpPr>
-          <p:cNvPr id="126" name=""/>
+          <p:cNvPr id="110" name=""/>
           <p:cNvSpPr txBox="1"/>
           <p:nvPr/>
         </p:nvSpPr>
@@ -5851,7 +5584,7 @@
       </p:sp>
       <p:pic>
         <p:nvPicPr>
-          <p:cNvPr id="127" name=""/>
+          <p:cNvPr id="111" name=""/>
           <p:cNvPicPr/>
           <p:nvPr/>
         </p:nvPicPr>
@@ -5875,185 +5608,7 @@
       </p:pic>
       <p:sp>
         <p:nvSpPr>
-          <p:cNvPr id="128" name=""/>
-          <p:cNvSpPr txBox="1"/>
-          <p:nvPr/>
-        </p:nvSpPr>
-        <p:spPr>
-          <a:xfrm>
-            <a:off x="1943280" y="1088640"/>
-            <a:ext cx="1548360" cy="322560"/>
-          </a:xfrm>
-          <a:prstGeom prst="rect">
-            <a:avLst/>
-          </a:prstGeom>
-          <a:noFill/>
-          <a:ln w="28800">
-            <a:solidFill>
-              <a:srgbClr val="D97706"/>
-            </a:solidFill>
-            <a:round/>
-          </a:ln>
-        </p:spPr>
-        <p:txBody>
-          <a:bodyPr lIns="104400" tIns="59400" rIns="104400" bIns="59400" anchor="t">
-            <a:spAutoFit/>
-          </a:bodyPr>
-          <a:p>
-            <a:endParaRPr lang="en-US" sz="1800" b="0" u="none" strike="noStrike">
-              <a:solidFill>
-                <a:srgbClr val="000000"/>
-              </a:solidFill>
-              <a:effectLst/>
-              <a:uFillTx/>
-              <a:latin typeface="Arial"/>
-            </a:endParaRPr>
-          </a:p>
-        </p:txBody>
-      </p:sp>
-      <p:sp>
-        <p:nvSpPr>
-          <p:cNvPr id="129" name=""/>
-          <p:cNvSpPr txBox="1"/>
-          <p:nvPr/>
-        </p:nvSpPr>
-        <p:spPr>
-          <a:xfrm>
-            <a:off x="1943280" y="1440000"/>
-            <a:ext cx="3294000" cy="201600"/>
-          </a:xfrm>
-          <a:prstGeom prst="rect">
-            <a:avLst/>
-          </a:prstGeom>
-          <a:solidFill>
-            <a:srgbClr val="103E3A"/>
-          </a:solidFill>
-          <a:ln w="14400">
-            <a:solidFill>
-              <a:srgbClr val="E6BF71"/>
-            </a:solidFill>
-            <a:round/>
-          </a:ln>
-        </p:spPr>
-        <p:txBody>
-          <a:bodyPr lIns="79200" tIns="28800" rIns="79200" bIns="28800" anchor="t">
-            <a:spAutoFit/>
-          </a:bodyPr>
-          <a:p>
-            <a:r>
-              <a:rPr lang="en-US" sz="950" b="1" u="none" strike="noStrike">
-                <a:solidFill>
-                  <a:srgbClr val="FFFFFF"/>
-                </a:solidFill>
-                <a:effectLst/>
-                <a:uFillTx/>
-                <a:latin typeface="Arial"/>
-              </a:rPr>
-              <a:t>Topbar flipped RTL · theme &amp; language toggles</a:t>
-            </a:r>
-            <a:endParaRPr lang="en-US" sz="950" b="0" u="none" strike="noStrike">
-              <a:solidFill>
-                <a:srgbClr val="FFFFFF"/>
-              </a:solidFill>
-              <a:effectLst/>
-              <a:uFillTx/>
-              <a:latin typeface="Arial"/>
-            </a:endParaRPr>
-          </a:p>
-        </p:txBody>
-      </p:sp>
-      <p:sp>
-        <p:nvSpPr>
-          <p:cNvPr id="130" name=""/>
-          <p:cNvSpPr txBox="1"/>
-          <p:nvPr/>
-        </p:nvSpPr>
-        <p:spPr>
-          <a:xfrm>
-            <a:off x="6975360" y="1088640"/>
-            <a:ext cx="1225800" cy="2016000"/>
-          </a:xfrm>
-          <a:prstGeom prst="rect">
-            <a:avLst/>
-          </a:prstGeom>
-          <a:noFill/>
-          <a:ln w="28800">
-            <a:solidFill>
-              <a:srgbClr val="D97706"/>
-            </a:solidFill>
-            <a:round/>
-          </a:ln>
-        </p:spPr>
-        <p:txBody>
-          <a:bodyPr lIns="104400" tIns="59400" rIns="104400" bIns="59400" anchor="t">
-            <a:spAutoFit/>
-          </a:bodyPr>
-          <a:p>
-            <a:endParaRPr lang="en-US" sz="1800" b="0" u="none" strike="noStrike">
-              <a:solidFill>
-                <a:srgbClr val="000000"/>
-              </a:solidFill>
-              <a:effectLst/>
-              <a:uFillTx/>
-              <a:latin typeface="Arial"/>
-            </a:endParaRPr>
-          </a:p>
-        </p:txBody>
-      </p:sp>
-      <p:sp>
-        <p:nvSpPr>
-          <p:cNvPr id="131" name=""/>
-          <p:cNvSpPr txBox="1"/>
-          <p:nvPr/>
-        </p:nvSpPr>
-        <p:spPr>
-          <a:xfrm>
-            <a:off x="6975360" y="3133440"/>
-            <a:ext cx="2678400" cy="201600"/>
-          </a:xfrm>
-          <a:prstGeom prst="rect">
-            <a:avLst/>
-          </a:prstGeom>
-          <a:solidFill>
-            <a:srgbClr val="103E3A"/>
-          </a:solidFill>
-          <a:ln w="14400">
-            <a:solidFill>
-              <a:srgbClr val="E6BF71"/>
-            </a:solidFill>
-            <a:round/>
-          </a:ln>
-        </p:spPr>
-        <p:txBody>
-          <a:bodyPr lIns="79200" tIns="28800" rIns="79200" bIns="28800" anchor="t">
-            <a:spAutoFit/>
-          </a:bodyPr>
-          <a:p>
-            <a:r>
-              <a:rPr lang="en-US" sz="950" b="1" u="none" strike="noStrike">
-                <a:solidFill>
-                  <a:srgbClr val="FFFFFF"/>
-                </a:solidFill>
-                <a:effectLst/>
-                <a:uFillTx/>
-                <a:latin typeface="Arial"/>
-              </a:rPr>
-              <a:t>Arabic RTL navigation &amp; dark palette</a:t>
-            </a:r>
-            <a:endParaRPr lang="en-US" sz="950" b="0" u="none" strike="noStrike">
-              <a:solidFill>
-                <a:srgbClr val="FFFFFF"/>
-              </a:solidFill>
-              <a:effectLst/>
-              <a:uFillTx/>
-              <a:latin typeface="Arial"/>
-            </a:endParaRPr>
-          </a:p>
-        </p:txBody>
-      </p:sp>
-      <p:sp>
-        <p:nvSpPr>
-          <p:cNvPr id="132" name=""/>
+          <p:cNvPr id="112" name=""/>
           <p:cNvSpPr txBox="1"/>
           <p:nvPr/>
         </p:nvSpPr>
@@ -6136,7 +5691,7 @@
       </p:grpSpPr>
       <p:sp>
         <p:nvSpPr>
-          <p:cNvPr id="133" name=""/>
+          <p:cNvPr id="113" name=""/>
           <p:cNvSpPr txBox="1"/>
           <p:nvPr/>
         </p:nvSpPr>
@@ -6182,7 +5737,7 @@
       </p:sp>
       <p:sp>
         <p:nvSpPr>
-          <p:cNvPr id="134" name=""/>
+          <p:cNvPr id="114" name=""/>
           <p:cNvSpPr txBox="1"/>
           <p:nvPr/>
         </p:nvSpPr>
@@ -6219,7 +5774,7 @@
       </p:sp>
       <p:pic>
         <p:nvPicPr>
-          <p:cNvPr id="135" name=""/>
+          <p:cNvPr id="115" name=""/>
           <p:cNvPicPr/>
           <p:nvPr/>
         </p:nvPicPr>
@@ -6243,96 +5798,7 @@
       </p:pic>
       <p:sp>
         <p:nvSpPr>
-          <p:cNvPr id="136" name=""/>
-          <p:cNvSpPr txBox="1"/>
-          <p:nvPr/>
-        </p:nvSpPr>
-        <p:spPr>
-          <a:xfrm>
-            <a:off x="3104640" y="2862720"/>
-            <a:ext cx="4838400" cy="645120"/>
-          </a:xfrm>
-          <a:prstGeom prst="rect">
-            <a:avLst/>
-          </a:prstGeom>
-          <a:noFill/>
-          <a:ln w="28800">
-            <a:solidFill>
-              <a:srgbClr val="D97706"/>
-            </a:solidFill>
-            <a:round/>
-          </a:ln>
-        </p:spPr>
-        <p:txBody>
-          <a:bodyPr lIns="104400" tIns="59400" rIns="104400" bIns="59400" anchor="t">
-            <a:spAutoFit/>
-          </a:bodyPr>
-          <a:p>
-            <a:endParaRPr lang="en-US" sz="1800" b="0" u="none" strike="noStrike">
-              <a:solidFill>
-                <a:srgbClr val="000000"/>
-              </a:solidFill>
-              <a:effectLst/>
-              <a:uFillTx/>
-              <a:latin typeface="Arial"/>
-            </a:endParaRPr>
-          </a:p>
-        </p:txBody>
-      </p:sp>
-      <p:sp>
-        <p:nvSpPr>
-          <p:cNvPr id="137" name=""/>
-          <p:cNvSpPr txBox="1"/>
-          <p:nvPr/>
-        </p:nvSpPr>
-        <p:spPr>
-          <a:xfrm>
-            <a:off x="3104640" y="2639520"/>
-            <a:ext cx="2199600" cy="201600"/>
-          </a:xfrm>
-          <a:prstGeom prst="rect">
-            <a:avLst/>
-          </a:prstGeom>
-          <a:solidFill>
-            <a:srgbClr val="103E3A"/>
-          </a:solidFill>
-          <a:ln w="14400">
-            <a:solidFill>
-              <a:srgbClr val="E6BF71"/>
-            </a:solidFill>
-            <a:round/>
-          </a:ln>
-        </p:spPr>
-        <p:txBody>
-          <a:bodyPr lIns="79200" tIns="28800" rIns="79200" bIns="28800" anchor="t">
-            <a:spAutoFit/>
-          </a:bodyPr>
-          <a:p>
-            <a:r>
-              <a:rPr lang="en-US" sz="950" b="1" u="none" strike="noStrike">
-                <a:solidFill>
-                  <a:srgbClr val="FFFFFF"/>
-                </a:solidFill>
-                <a:effectLst/>
-                <a:uFillTx/>
-                <a:latin typeface="Arial"/>
-              </a:rPr>
-              <a:t>Own rows tinted + 'You' badge</a:t>
-            </a:r>
-            <a:endParaRPr lang="en-US" sz="950" b="0" u="none" strike="noStrike">
-              <a:solidFill>
-                <a:srgbClr val="FFFFFF"/>
-              </a:solidFill>
-              <a:effectLst/>
-              <a:uFillTx/>
-              <a:latin typeface="Arial"/>
-            </a:endParaRPr>
-          </a:p>
-        </p:txBody>
-      </p:sp>
-      <p:sp>
-        <p:nvSpPr>
-          <p:cNvPr id="138" name=""/>
+          <p:cNvPr id="116" name=""/>
           <p:cNvSpPr txBox="1"/>
           <p:nvPr/>
         </p:nvSpPr>
@@ -6415,7 +5881,7 @@
       </p:grpSpPr>
       <p:sp>
         <p:nvSpPr>
-          <p:cNvPr id="139" name=""/>
+          <p:cNvPr id="117" name=""/>
           <p:cNvSpPr txBox="1"/>
           <p:nvPr/>
         </p:nvSpPr>
@@ -6461,7 +5927,7 @@
       </p:sp>
       <p:sp>
         <p:nvSpPr>
-          <p:cNvPr id="140" name=""/>
+          <p:cNvPr id="118" name=""/>
           <p:cNvSpPr txBox="1"/>
           <p:nvPr/>
         </p:nvSpPr>
@@ -6498,7 +5964,7 @@
       </p:sp>
       <p:pic>
         <p:nvPicPr>
-          <p:cNvPr id="141" name=""/>
+          <p:cNvPr id="119" name=""/>
           <p:cNvPicPr/>
           <p:nvPr/>
         </p:nvPicPr>
@@ -6522,7 +5988,7 @@
       </p:pic>
       <p:sp>
         <p:nvSpPr>
-          <p:cNvPr id="142" name=""/>
+          <p:cNvPr id="120" name=""/>
           <p:cNvSpPr txBox="1"/>
           <p:nvPr/>
         </p:nvSpPr>
@@ -6605,7 +6071,7 @@
       </p:grpSpPr>
       <p:sp>
         <p:nvSpPr>
-          <p:cNvPr id="143" name=""/>
+          <p:cNvPr id="121" name=""/>
           <p:cNvSpPr txBox="1"/>
           <p:nvPr/>
         </p:nvSpPr>
@@ -6651,7 +6117,7 @@
       </p:sp>
       <p:sp>
         <p:nvSpPr>
-          <p:cNvPr id="144" name=""/>
+          <p:cNvPr id="122" name=""/>
           <p:cNvSpPr txBox="1"/>
           <p:nvPr/>
         </p:nvSpPr>
@@ -6688,7 +6154,7 @@
       </p:sp>
       <p:pic>
         <p:nvPicPr>
-          <p:cNvPr id="145" name=""/>
+          <p:cNvPr id="123" name=""/>
           <p:cNvPicPr/>
           <p:nvPr/>
         </p:nvPicPr>
@@ -6712,7 +6178,7 @@
       </p:pic>
       <p:sp>
         <p:nvSpPr>
-          <p:cNvPr id="146" name=""/>
+          <p:cNvPr id="124" name=""/>
           <p:cNvSpPr txBox="1"/>
           <p:nvPr/>
         </p:nvSpPr>
@@ -7179,7 +6645,7 @@
       </p:grpSpPr>
       <p:sp>
         <p:nvSpPr>
-          <p:cNvPr id="147" name=""/>
+          <p:cNvPr id="125" name=""/>
           <p:cNvSpPr txBox="1"/>
           <p:nvPr/>
         </p:nvSpPr>
@@ -7225,7 +6691,7 @@
       </p:sp>
       <p:sp>
         <p:nvSpPr>
-          <p:cNvPr id="148" name=""/>
+          <p:cNvPr id="126" name=""/>
           <p:cNvSpPr txBox="1"/>
           <p:nvPr/>
         </p:nvSpPr>
@@ -7262,7 +6728,7 @@
       </p:sp>
       <p:pic>
         <p:nvPicPr>
-          <p:cNvPr id="149" name=""/>
+          <p:cNvPr id="127" name=""/>
           <p:cNvPicPr/>
           <p:nvPr/>
         </p:nvPicPr>
@@ -7286,7 +6752,7 @@
       </p:pic>
       <p:sp>
         <p:nvSpPr>
-          <p:cNvPr id="150" name=""/>
+          <p:cNvPr id="128" name=""/>
           <p:cNvSpPr txBox="1"/>
           <p:nvPr/>
         </p:nvSpPr>
@@ -7369,7 +6835,7 @@
       </p:grpSpPr>
       <p:sp>
         <p:nvSpPr>
-          <p:cNvPr id="151" name=""/>
+          <p:cNvPr id="129" name=""/>
           <p:cNvSpPr txBox="1"/>
           <p:nvPr/>
         </p:nvSpPr>
@@ -7415,7 +6881,7 @@
       </p:sp>
       <p:sp>
         <p:nvSpPr>
-          <p:cNvPr id="152" name=""/>
+          <p:cNvPr id="130" name=""/>
           <p:cNvSpPr txBox="1"/>
           <p:nvPr/>
         </p:nvSpPr>
@@ -7452,7 +6918,7 @@
       </p:sp>
       <p:pic>
         <p:nvPicPr>
-          <p:cNvPr id="153" name=""/>
+          <p:cNvPr id="131" name=""/>
           <p:cNvPicPr/>
           <p:nvPr/>
         </p:nvPicPr>
@@ -7476,96 +6942,7 @@
       </p:pic>
       <p:sp>
         <p:nvSpPr>
-          <p:cNvPr id="154" name=""/>
-          <p:cNvSpPr txBox="1"/>
-          <p:nvPr/>
-        </p:nvSpPr>
-        <p:spPr>
-          <a:xfrm>
-            <a:off x="3104640" y="1854720"/>
-            <a:ext cx="1677240" cy="362880"/>
-          </a:xfrm>
-          <a:prstGeom prst="rect">
-            <a:avLst/>
-          </a:prstGeom>
-          <a:noFill/>
-          <a:ln w="28800">
-            <a:solidFill>
-              <a:srgbClr val="D97706"/>
-            </a:solidFill>
-            <a:round/>
-          </a:ln>
-        </p:spPr>
-        <p:txBody>
-          <a:bodyPr lIns="104400" tIns="59400" rIns="104400" bIns="59400" anchor="t">
-            <a:spAutoFit/>
-          </a:bodyPr>
-          <a:p>
-            <a:endParaRPr lang="en-US" sz="1800" b="0" u="none" strike="noStrike">
-              <a:solidFill>
-                <a:srgbClr val="000000"/>
-              </a:solidFill>
-              <a:effectLst/>
-              <a:uFillTx/>
-              <a:latin typeface="Arial"/>
-            </a:endParaRPr>
-          </a:p>
-        </p:txBody>
-      </p:sp>
-      <p:sp>
-        <p:nvSpPr>
-          <p:cNvPr id="155" name=""/>
-          <p:cNvSpPr txBox="1"/>
-          <p:nvPr/>
-        </p:nvSpPr>
-        <p:spPr>
-          <a:xfrm>
-            <a:off x="3104640" y="1631520"/>
-            <a:ext cx="2746800" cy="201600"/>
-          </a:xfrm>
-          <a:prstGeom prst="rect">
-            <a:avLst/>
-          </a:prstGeom>
-          <a:solidFill>
-            <a:srgbClr val="103E3A"/>
-          </a:solidFill>
-          <a:ln w="14400">
-            <a:solidFill>
-              <a:srgbClr val="E6BF71"/>
-            </a:solidFill>
-            <a:round/>
-          </a:ln>
-        </p:spPr>
-        <p:txBody>
-          <a:bodyPr lIns="79200" tIns="28800" rIns="79200" bIns="28800" anchor="t">
-            <a:spAutoFit/>
-          </a:bodyPr>
-          <a:p>
-            <a:r>
-              <a:rPr lang="en-US" sz="950" b="1" u="none" strike="noStrike">
-                <a:solidFill>
-                  <a:srgbClr val="FFFFFF"/>
-                </a:solidFill>
-                <a:effectLst/>
-                <a:uFillTx/>
-                <a:latin typeface="Arial"/>
-              </a:rPr>
-              <a:t>Defaults to Requests tab · CSV export</a:t>
-            </a:r>
-            <a:endParaRPr lang="en-US" sz="950" b="0" u="none" strike="noStrike">
-              <a:solidFill>
-                <a:srgbClr val="FFFFFF"/>
-              </a:solidFill>
-              <a:effectLst/>
-              <a:uFillTx/>
-              <a:latin typeface="Arial"/>
-            </a:endParaRPr>
-          </a:p>
-        </p:txBody>
-      </p:sp>
-      <p:sp>
-        <p:nvSpPr>
-          <p:cNvPr id="156" name=""/>
+          <p:cNvPr id="132" name=""/>
           <p:cNvSpPr txBox="1"/>
           <p:nvPr/>
         </p:nvSpPr>
@@ -7648,7 +7025,7 @@
       </p:grpSpPr>
       <p:sp>
         <p:nvSpPr>
-          <p:cNvPr id="157" name=""/>
+          <p:cNvPr id="133" name=""/>
           <p:cNvSpPr txBox="1"/>
           <p:nvPr/>
         </p:nvSpPr>
@@ -7694,7 +7071,7 @@
       </p:sp>
       <p:sp>
         <p:nvSpPr>
-          <p:cNvPr id="158" name=""/>
+          <p:cNvPr id="134" name=""/>
           <p:cNvSpPr txBox="1"/>
           <p:nvPr/>
         </p:nvSpPr>
@@ -7731,7 +7108,7 @@
       </p:sp>
       <p:pic>
         <p:nvPicPr>
-          <p:cNvPr id="159" name=""/>
+          <p:cNvPr id="135" name=""/>
           <p:cNvPicPr/>
           <p:nvPr/>
         </p:nvPicPr>
@@ -7755,7 +7132,7 @@
       </p:pic>
       <p:sp>
         <p:nvSpPr>
-          <p:cNvPr id="160" name=""/>
+          <p:cNvPr id="136" name=""/>
           <p:cNvSpPr txBox="1"/>
           <p:nvPr/>
         </p:nvSpPr>
@@ -7838,7 +7215,7 @@
       </p:grpSpPr>
       <p:sp>
         <p:nvSpPr>
-          <p:cNvPr id="161" name=""/>
+          <p:cNvPr id="137" name=""/>
           <p:cNvSpPr txBox="1"/>
           <p:nvPr/>
         </p:nvSpPr>
@@ -7884,7 +7261,7 @@
       </p:sp>
       <p:sp>
         <p:nvSpPr>
-          <p:cNvPr id="162" name=""/>
+          <p:cNvPr id="138" name=""/>
           <p:cNvSpPr txBox="1"/>
           <p:nvPr/>
         </p:nvSpPr>
@@ -7921,7 +7298,7 @@
       </p:sp>
       <p:sp>
         <p:nvSpPr>
-          <p:cNvPr id="163" name=""/>
+          <p:cNvPr id="139" name=""/>
           <p:cNvSpPr txBox="1"/>
           <p:nvPr/>
         </p:nvSpPr>
@@ -7958,7 +7335,7 @@
       </p:sp>
       <p:sp>
         <p:nvSpPr>
-          <p:cNvPr id="164" name=""/>
+          <p:cNvPr id="140" name=""/>
           <p:cNvSpPr txBox="1"/>
           <p:nvPr/>
         </p:nvSpPr>
@@ -8009,7 +7386,7 @@
       </p:sp>
       <p:sp>
         <p:nvSpPr>
-          <p:cNvPr id="165" name=""/>
+          <p:cNvPr id="141" name=""/>
           <p:cNvSpPr txBox="1"/>
           <p:nvPr/>
         </p:nvSpPr>
@@ -8046,7 +7423,7 @@
       </p:sp>
       <p:sp>
         <p:nvSpPr>
-          <p:cNvPr id="166" name=""/>
+          <p:cNvPr id="142" name=""/>
           <p:cNvSpPr txBox="1"/>
           <p:nvPr/>
         </p:nvSpPr>
@@ -8097,7 +7474,7 @@
       </p:sp>
       <p:sp>
         <p:nvSpPr>
-          <p:cNvPr id="167" name=""/>
+          <p:cNvPr id="143" name=""/>
           <p:cNvSpPr txBox="1"/>
           <p:nvPr/>
         </p:nvSpPr>
@@ -8134,7 +7511,7 @@
       </p:sp>
       <p:sp>
         <p:nvSpPr>
-          <p:cNvPr id="168" name=""/>
+          <p:cNvPr id="144" name=""/>
           <p:cNvSpPr txBox="1"/>
           <p:nvPr/>
         </p:nvSpPr>
@@ -8185,7 +7562,7 @@
       </p:sp>
       <p:sp>
         <p:nvSpPr>
-          <p:cNvPr id="169" name=""/>
+          <p:cNvPr id="145" name=""/>
           <p:cNvSpPr txBox="1"/>
           <p:nvPr/>
         </p:nvSpPr>
@@ -8222,7 +7599,7 @@
       </p:sp>
       <p:sp>
         <p:nvSpPr>
-          <p:cNvPr id="170" name=""/>
+          <p:cNvPr id="146" name=""/>
           <p:cNvSpPr txBox="1"/>
           <p:nvPr/>
         </p:nvSpPr>
@@ -8310,7 +7687,7 @@
       </p:grpSpPr>
       <p:sp>
         <p:nvSpPr>
-          <p:cNvPr id="171" name=""/>
+          <p:cNvPr id="147" name=""/>
           <p:cNvSpPr txBox="1"/>
           <p:nvPr/>
         </p:nvSpPr>
@@ -8356,7 +7733,7 @@
       </p:sp>
       <p:sp>
         <p:nvSpPr>
-          <p:cNvPr id="172" name=""/>
+          <p:cNvPr id="148" name=""/>
           <p:cNvSpPr txBox="1"/>
           <p:nvPr/>
         </p:nvSpPr>
@@ -8393,7 +7770,7 @@
       </p:sp>
       <p:sp>
         <p:nvSpPr>
-          <p:cNvPr id="173" name=""/>
+          <p:cNvPr id="149" name=""/>
           <p:cNvSpPr txBox="1"/>
           <p:nvPr/>
         </p:nvSpPr>
@@ -8430,7 +7807,7 @@
       </p:sp>
       <p:sp>
         <p:nvSpPr>
-          <p:cNvPr id="174" name=""/>
+          <p:cNvPr id="150" name=""/>
           <p:cNvSpPr txBox="1"/>
           <p:nvPr/>
         </p:nvSpPr>
@@ -8481,7 +7858,7 @@
       </p:sp>
       <p:sp>
         <p:nvSpPr>
-          <p:cNvPr id="175" name=""/>
+          <p:cNvPr id="151" name=""/>
           <p:cNvSpPr txBox="1"/>
           <p:nvPr/>
         </p:nvSpPr>
@@ -8518,7 +7895,7 @@
       </p:sp>
       <p:sp>
         <p:nvSpPr>
-          <p:cNvPr id="176" name=""/>
+          <p:cNvPr id="152" name=""/>
           <p:cNvSpPr txBox="1"/>
           <p:nvPr/>
         </p:nvSpPr>
@@ -8569,7 +7946,7 @@
       </p:sp>
       <p:sp>
         <p:nvSpPr>
-          <p:cNvPr id="177" name=""/>
+          <p:cNvPr id="153" name=""/>
           <p:cNvSpPr txBox="1"/>
           <p:nvPr/>
         </p:nvSpPr>
@@ -8606,7 +7983,7 @@
       </p:sp>
       <p:sp>
         <p:nvSpPr>
-          <p:cNvPr id="178" name=""/>
+          <p:cNvPr id="154" name=""/>
           <p:cNvSpPr txBox="1"/>
           <p:nvPr/>
         </p:nvSpPr>
@@ -8657,7 +8034,7 @@
       </p:sp>
       <p:sp>
         <p:nvSpPr>
-          <p:cNvPr id="179" name=""/>
+          <p:cNvPr id="155" name=""/>
           <p:cNvSpPr txBox="1"/>
           <p:nvPr/>
         </p:nvSpPr>
@@ -8694,7 +8071,7 @@
       </p:sp>
       <p:sp>
         <p:nvSpPr>
-          <p:cNvPr id="180" name=""/>
+          <p:cNvPr id="156" name=""/>
           <p:cNvSpPr txBox="1"/>
           <p:nvPr/>
         </p:nvSpPr>
@@ -8782,7 +8159,7 @@
       </p:grpSpPr>
       <p:sp>
         <p:nvSpPr>
-          <p:cNvPr id="181" name=""/>
+          <p:cNvPr id="157" name=""/>
           <p:cNvSpPr txBox="1"/>
           <p:nvPr/>
         </p:nvSpPr>
@@ -8828,7 +8205,7 @@
       </p:sp>
       <p:sp>
         <p:nvSpPr>
-          <p:cNvPr id="182" name=""/>
+          <p:cNvPr id="158" name=""/>
           <p:cNvSpPr txBox="1"/>
           <p:nvPr/>
         </p:nvSpPr>
@@ -8865,7 +8242,7 @@
       </p:sp>
       <p:sp>
         <p:nvSpPr>
-          <p:cNvPr id="183" name=""/>
+          <p:cNvPr id="159" name=""/>
           <p:cNvSpPr txBox="1"/>
           <p:nvPr/>
         </p:nvSpPr>
@@ -8902,7 +8279,7 @@
       </p:sp>
       <p:sp>
         <p:nvSpPr>
-          <p:cNvPr id="184" name=""/>
+          <p:cNvPr id="160" name=""/>
           <p:cNvSpPr txBox="1"/>
           <p:nvPr/>
         </p:nvSpPr>
@@ -8953,7 +8330,7 @@
       </p:sp>
       <p:sp>
         <p:nvSpPr>
-          <p:cNvPr id="185" name=""/>
+          <p:cNvPr id="161" name=""/>
           <p:cNvSpPr txBox="1"/>
           <p:nvPr/>
         </p:nvSpPr>
@@ -8990,7 +8367,7 @@
       </p:sp>
       <p:sp>
         <p:nvSpPr>
-          <p:cNvPr id="186" name=""/>
+          <p:cNvPr id="162" name=""/>
           <p:cNvSpPr txBox="1"/>
           <p:nvPr/>
         </p:nvSpPr>
@@ -9041,7 +8418,7 @@
       </p:sp>
       <p:sp>
         <p:nvSpPr>
-          <p:cNvPr id="187" name=""/>
+          <p:cNvPr id="163" name=""/>
           <p:cNvSpPr txBox="1"/>
           <p:nvPr/>
         </p:nvSpPr>
@@ -9078,7 +8455,7 @@
       </p:sp>
       <p:sp>
         <p:nvSpPr>
-          <p:cNvPr id="188" name=""/>
+          <p:cNvPr id="164" name=""/>
           <p:cNvSpPr txBox="1"/>
           <p:nvPr/>
         </p:nvSpPr>
@@ -9166,7 +8543,7 @@
       </p:grpSpPr>
       <p:sp>
         <p:nvSpPr>
-          <p:cNvPr id="189" name=""/>
+          <p:cNvPr id="165" name=""/>
           <p:cNvSpPr txBox="1"/>
           <p:nvPr/>
         </p:nvSpPr>
@@ -9212,7 +8589,7 @@
       </p:sp>
       <p:sp>
         <p:nvSpPr>
-          <p:cNvPr id="190" name=""/>
+          <p:cNvPr id="166" name=""/>
           <p:cNvSpPr txBox="1"/>
           <p:nvPr/>
         </p:nvSpPr>
@@ -9249,7 +8626,7 @@
       </p:sp>
       <p:sp>
         <p:nvSpPr>
-          <p:cNvPr id="191" name=""/>
+          <p:cNvPr id="167" name=""/>
           <p:cNvSpPr txBox="1"/>
           <p:nvPr/>
         </p:nvSpPr>
@@ -9286,7 +8663,7 @@
       </p:sp>
       <p:sp>
         <p:nvSpPr>
-          <p:cNvPr id="192" name=""/>
+          <p:cNvPr id="168" name=""/>
           <p:cNvSpPr txBox="1"/>
           <p:nvPr/>
         </p:nvSpPr>
@@ -9337,7 +8714,7 @@
       </p:sp>
       <p:sp>
         <p:nvSpPr>
-          <p:cNvPr id="193" name=""/>
+          <p:cNvPr id="169" name=""/>
           <p:cNvSpPr txBox="1"/>
           <p:nvPr/>
         </p:nvSpPr>
@@ -9374,7 +8751,7 @@
       </p:sp>
       <p:sp>
         <p:nvSpPr>
-          <p:cNvPr id="194" name=""/>
+          <p:cNvPr id="170" name=""/>
           <p:cNvSpPr txBox="1"/>
           <p:nvPr/>
         </p:nvSpPr>
@@ -9425,7 +8802,7 @@
       </p:sp>
       <p:sp>
         <p:nvSpPr>
-          <p:cNvPr id="195" name=""/>
+          <p:cNvPr id="171" name=""/>
           <p:cNvSpPr txBox="1"/>
           <p:nvPr/>
         </p:nvSpPr>
@@ -9462,7 +8839,7 @@
       </p:sp>
       <p:sp>
         <p:nvSpPr>
-          <p:cNvPr id="196" name=""/>
+          <p:cNvPr id="172" name=""/>
           <p:cNvSpPr txBox="1"/>
           <p:nvPr/>
         </p:nvSpPr>
@@ -9513,7 +8890,7 @@
       </p:sp>
       <p:sp>
         <p:nvSpPr>
-          <p:cNvPr id="197" name=""/>
+          <p:cNvPr id="173" name=""/>
           <p:cNvSpPr txBox="1"/>
           <p:nvPr/>
         </p:nvSpPr>
@@ -9550,7 +8927,7 @@
       </p:sp>
       <p:sp>
         <p:nvSpPr>
-          <p:cNvPr id="198" name=""/>
+          <p:cNvPr id="174" name=""/>
           <p:cNvSpPr txBox="1"/>
           <p:nvPr/>
         </p:nvSpPr>
@@ -9638,7 +9015,7 @@
       </p:grpSpPr>
       <p:sp>
         <p:nvSpPr>
-          <p:cNvPr id="199" name=""/>
+          <p:cNvPr id="175" name=""/>
           <p:cNvSpPr txBox="1"/>
           <p:nvPr/>
         </p:nvSpPr>
@@ -9684,7 +9061,7 @@
       </p:sp>
       <p:sp>
         <p:nvSpPr>
-          <p:cNvPr id="200" name=""/>
+          <p:cNvPr id="176" name=""/>
           <p:cNvSpPr txBox="1"/>
           <p:nvPr/>
         </p:nvSpPr>
@@ -9721,7 +9098,7 @@
       </p:sp>
       <p:sp>
         <p:nvSpPr>
-          <p:cNvPr id="201" name=""/>
+          <p:cNvPr id="177" name=""/>
           <p:cNvSpPr txBox="1"/>
           <p:nvPr/>
         </p:nvSpPr>
@@ -9758,7 +9135,7 @@
       </p:sp>
       <p:sp>
         <p:nvSpPr>
-          <p:cNvPr id="202" name=""/>
+          <p:cNvPr id="178" name=""/>
           <p:cNvSpPr txBox="1"/>
           <p:nvPr/>
         </p:nvSpPr>
@@ -9809,7 +9186,7 @@
       </p:sp>
       <p:sp>
         <p:nvSpPr>
-          <p:cNvPr id="203" name=""/>
+          <p:cNvPr id="179" name=""/>
           <p:cNvSpPr txBox="1"/>
           <p:nvPr/>
         </p:nvSpPr>
@@ -9846,7 +9223,7 @@
       </p:sp>
       <p:sp>
         <p:nvSpPr>
-          <p:cNvPr id="204" name=""/>
+          <p:cNvPr id="180" name=""/>
           <p:cNvSpPr txBox="1"/>
           <p:nvPr/>
         </p:nvSpPr>
@@ -9897,7 +9274,7 @@
       </p:sp>
       <p:sp>
         <p:nvSpPr>
-          <p:cNvPr id="205" name=""/>
+          <p:cNvPr id="181" name=""/>
           <p:cNvSpPr txBox="1"/>
           <p:nvPr/>
         </p:nvSpPr>
@@ -9934,7 +9311,7 @@
       </p:sp>
       <p:sp>
         <p:nvSpPr>
-          <p:cNvPr id="206" name=""/>
+          <p:cNvPr id="182" name=""/>
           <p:cNvSpPr txBox="1"/>
           <p:nvPr/>
         </p:nvSpPr>
@@ -10022,7 +9399,7 @@
       </p:grpSpPr>
       <p:sp>
         <p:nvSpPr>
-          <p:cNvPr id="207" name=""/>
+          <p:cNvPr id="183" name=""/>
           <p:cNvSpPr txBox="1"/>
           <p:nvPr/>
         </p:nvSpPr>
@@ -10068,7 +9445,7 @@
       </p:sp>
       <p:sp>
         <p:nvSpPr>
-          <p:cNvPr id="208" name=""/>
+          <p:cNvPr id="184" name=""/>
           <p:cNvSpPr txBox="1"/>
           <p:nvPr/>
         </p:nvSpPr>
@@ -10105,7 +9482,7 @@
       </p:sp>
       <p:sp>
         <p:nvSpPr>
-          <p:cNvPr id="209" name=""/>
+          <p:cNvPr id="185" name=""/>
           <p:cNvSpPr txBox="1"/>
           <p:nvPr/>
         </p:nvSpPr>
@@ -10142,7 +9519,7 @@
       </p:sp>
       <p:sp>
         <p:nvSpPr>
-          <p:cNvPr id="210" name=""/>
+          <p:cNvPr id="186" name=""/>
           <p:cNvSpPr txBox="1"/>
           <p:nvPr/>
         </p:nvSpPr>
@@ -10193,7 +9570,7 @@
       </p:sp>
       <p:sp>
         <p:nvSpPr>
-          <p:cNvPr id="211" name=""/>
+          <p:cNvPr id="187" name=""/>
           <p:cNvSpPr txBox="1"/>
           <p:nvPr/>
         </p:nvSpPr>
@@ -10230,7 +9607,7 @@
       </p:sp>
       <p:sp>
         <p:nvSpPr>
-          <p:cNvPr id="212" name=""/>
+          <p:cNvPr id="188" name=""/>
           <p:cNvSpPr txBox="1"/>
           <p:nvPr/>
         </p:nvSpPr>
@@ -10281,7 +9658,7 @@
       </p:sp>
       <p:sp>
         <p:nvSpPr>
-          <p:cNvPr id="213" name=""/>
+          <p:cNvPr id="189" name=""/>
           <p:cNvSpPr txBox="1"/>
           <p:nvPr/>
         </p:nvSpPr>
@@ -10318,7 +9695,7 @@
       </p:sp>
       <p:sp>
         <p:nvSpPr>
-          <p:cNvPr id="214" name=""/>
+          <p:cNvPr id="190" name=""/>
           <p:cNvSpPr txBox="1"/>
           <p:nvPr/>
         </p:nvSpPr>
@@ -10406,7 +9783,7 @@
       </p:grpSpPr>
       <p:sp>
         <p:nvSpPr>
-          <p:cNvPr id="215" name=""/>
+          <p:cNvPr id="191" name=""/>
           <p:cNvSpPr txBox="1"/>
           <p:nvPr/>
         </p:nvSpPr>
@@ -10452,7 +9829,7 @@
       </p:sp>
       <p:sp>
         <p:nvSpPr>
-          <p:cNvPr id="216" name=""/>
+          <p:cNvPr id="192" name=""/>
           <p:cNvSpPr txBox="1"/>
           <p:nvPr/>
         </p:nvSpPr>
@@ -10489,7 +9866,7 @@
       </p:sp>
       <p:sp>
         <p:nvSpPr>
-          <p:cNvPr id="217" name=""/>
+          <p:cNvPr id="193" name=""/>
           <p:cNvSpPr txBox="1"/>
           <p:nvPr/>
         </p:nvSpPr>
@@ -10526,7 +9903,7 @@
       </p:sp>
       <p:sp>
         <p:nvSpPr>
-          <p:cNvPr id="218" name=""/>
+          <p:cNvPr id="194" name=""/>
           <p:cNvSpPr txBox="1"/>
           <p:nvPr/>
         </p:nvSpPr>
@@ -10577,7 +9954,7 @@
       </p:sp>
       <p:sp>
         <p:nvSpPr>
-          <p:cNvPr id="219" name=""/>
+          <p:cNvPr id="195" name=""/>
           <p:cNvSpPr txBox="1"/>
           <p:nvPr/>
         </p:nvSpPr>
@@ -10614,7 +9991,7 @@
       </p:sp>
       <p:sp>
         <p:nvSpPr>
-          <p:cNvPr id="220" name=""/>
+          <p:cNvPr id="196" name=""/>
           <p:cNvSpPr txBox="1"/>
           <p:nvPr/>
         </p:nvSpPr>
@@ -10665,7 +10042,7 @@
       </p:sp>
       <p:sp>
         <p:nvSpPr>
-          <p:cNvPr id="221" name=""/>
+          <p:cNvPr id="197" name=""/>
           <p:cNvSpPr txBox="1"/>
           <p:nvPr/>
         </p:nvSpPr>
@@ -10702,7 +10079,7 @@
       </p:sp>
       <p:sp>
         <p:nvSpPr>
-          <p:cNvPr id="222" name=""/>
+          <p:cNvPr id="198" name=""/>
           <p:cNvSpPr txBox="1"/>
           <p:nvPr/>
         </p:nvSpPr>
@@ -11174,7 +10551,7 @@
       </p:grpSpPr>
       <p:sp>
         <p:nvSpPr>
-          <p:cNvPr id="223" name=""/>
+          <p:cNvPr id="199" name=""/>
           <p:cNvSpPr txBox="1"/>
           <p:nvPr/>
         </p:nvSpPr>
@@ -11231,7 +10608,7 @@
       </p:sp>
       <p:sp>
         <p:nvSpPr>
-          <p:cNvPr id="224" name=""/>
+          <p:cNvPr id="200" name=""/>
           <p:cNvSpPr txBox="1"/>
           <p:nvPr/>
         </p:nvSpPr>
@@ -11268,7 +10645,7 @@
       </p:sp>
       <p:sp>
         <p:nvSpPr>
-          <p:cNvPr id="225" name=""/>
+          <p:cNvPr id="201" name=""/>
           <p:cNvSpPr txBox="1"/>
           <p:nvPr/>
         </p:nvSpPr>
@@ -12463,184 +11840,6 @@
         </p:nvSpPr>
         <p:spPr>
           <a:xfrm>
-            <a:off x="5298120" y="1330560"/>
-            <a:ext cx="2193480" cy="887040"/>
-          </a:xfrm>
-          <a:prstGeom prst="rect">
-            <a:avLst/>
-          </a:prstGeom>
-          <a:noFill/>
-          <a:ln w="28800">
-            <a:solidFill>
-              <a:srgbClr val="D97706"/>
-            </a:solidFill>
-            <a:round/>
-          </a:ln>
-        </p:spPr>
-        <p:txBody>
-          <a:bodyPr lIns="104400" tIns="59400" rIns="104400" bIns="59400" anchor="t">
-            <a:spAutoFit/>
-          </a:bodyPr>
-          <a:p>
-            <a:endParaRPr lang="en-US" sz="1800" b="0" u="none" strike="noStrike">
-              <a:solidFill>
-                <a:srgbClr val="000000"/>
-              </a:solidFill>
-              <a:effectLst/>
-              <a:uFillTx/>
-              <a:latin typeface="Arial"/>
-            </a:endParaRPr>
-          </a:p>
-        </p:txBody>
-      </p:sp>
-      <p:sp>
-        <p:nvSpPr>
-          <p:cNvPr id="59" name=""/>
-          <p:cNvSpPr txBox="1"/>
-          <p:nvPr/>
-        </p:nvSpPr>
-        <p:spPr>
-          <a:xfrm>
-            <a:off x="5298120" y="1107360"/>
-            <a:ext cx="1584000" cy="201600"/>
-          </a:xfrm>
-          <a:prstGeom prst="rect">
-            <a:avLst/>
-          </a:prstGeom>
-          <a:solidFill>
-            <a:srgbClr val="103E3A"/>
-          </a:solidFill>
-          <a:ln w="14400">
-            <a:solidFill>
-              <a:srgbClr val="E6BF71"/>
-            </a:solidFill>
-            <a:round/>
-          </a:ln>
-        </p:spPr>
-        <p:txBody>
-          <a:bodyPr lIns="79200" tIns="28800" rIns="79200" bIns="28800" anchor="t">
-            <a:spAutoFit/>
-          </a:bodyPr>
-          <a:p>
-            <a:r>
-              <a:rPr lang="en-US" sz="950" b="1" u="none" strike="noStrike">
-                <a:solidFill>
-                  <a:srgbClr val="FFFFFF"/>
-                </a:solidFill>
-                <a:effectLst/>
-                <a:uFillTx/>
-                <a:latin typeface="Arial"/>
-              </a:rPr>
-              <a:t>One-click demo roles</a:t>
-            </a:r>
-            <a:endParaRPr lang="en-US" sz="950" b="0" u="none" strike="noStrike">
-              <a:solidFill>
-                <a:srgbClr val="FFFFFF"/>
-              </a:solidFill>
-              <a:effectLst/>
-              <a:uFillTx/>
-              <a:latin typeface="Arial"/>
-            </a:endParaRPr>
-          </a:p>
-        </p:txBody>
-      </p:sp>
-      <p:sp>
-        <p:nvSpPr>
-          <p:cNvPr id="60" name=""/>
-          <p:cNvSpPr txBox="1"/>
-          <p:nvPr/>
-        </p:nvSpPr>
-        <p:spPr>
-          <a:xfrm>
-            <a:off x="2201400" y="1895040"/>
-            <a:ext cx="2193480" cy="564480"/>
-          </a:xfrm>
-          <a:prstGeom prst="rect">
-            <a:avLst/>
-          </a:prstGeom>
-          <a:noFill/>
-          <a:ln w="28800">
-            <a:solidFill>
-              <a:srgbClr val="D97706"/>
-            </a:solidFill>
-            <a:round/>
-          </a:ln>
-        </p:spPr>
-        <p:txBody>
-          <a:bodyPr lIns="104400" tIns="59400" rIns="104400" bIns="59400" anchor="t">
-            <a:spAutoFit/>
-          </a:bodyPr>
-          <a:p>
-            <a:endParaRPr lang="en-US" sz="1800" b="0" u="none" strike="noStrike">
-              <a:solidFill>
-                <a:srgbClr val="000000"/>
-              </a:solidFill>
-              <a:effectLst/>
-              <a:uFillTx/>
-              <a:latin typeface="Arial"/>
-            </a:endParaRPr>
-          </a:p>
-        </p:txBody>
-      </p:sp>
-      <p:sp>
-        <p:nvSpPr>
-          <p:cNvPr id="61" name=""/>
-          <p:cNvSpPr txBox="1"/>
-          <p:nvPr/>
-        </p:nvSpPr>
-        <p:spPr>
-          <a:xfrm>
-            <a:off x="2201400" y="2488320"/>
-            <a:ext cx="1926000" cy="201600"/>
-          </a:xfrm>
-          <a:prstGeom prst="rect">
-            <a:avLst/>
-          </a:prstGeom>
-          <a:solidFill>
-            <a:srgbClr val="103E3A"/>
-          </a:solidFill>
-          <a:ln w="14400">
-            <a:solidFill>
-              <a:srgbClr val="E6BF71"/>
-            </a:solidFill>
-            <a:round/>
-          </a:ln>
-        </p:spPr>
-        <p:txBody>
-          <a:bodyPr lIns="79200" tIns="28800" rIns="79200" bIns="28800" anchor="t">
-            <a:spAutoFit/>
-          </a:bodyPr>
-          <a:p>
-            <a:r>
-              <a:rPr lang="en-US" sz="950" b="1" u="none" strike="noStrike">
-                <a:solidFill>
-                  <a:srgbClr val="FFFFFF"/>
-                </a:solidFill>
-                <a:effectLst/>
-                <a:uFillTx/>
-                <a:latin typeface="Arial"/>
-              </a:rPr>
-              <a:t>Approved bilingual slogan</a:t>
-            </a:r>
-            <a:endParaRPr lang="en-US" sz="950" b="0" u="none" strike="noStrike">
-              <a:solidFill>
-                <a:srgbClr val="FFFFFF"/>
-              </a:solidFill>
-              <a:effectLst/>
-              <a:uFillTx/>
-              <a:latin typeface="Arial"/>
-            </a:endParaRPr>
-          </a:p>
-        </p:txBody>
-      </p:sp>
-      <p:sp>
-        <p:nvSpPr>
-          <p:cNvPr id="62" name=""/>
-          <p:cNvSpPr txBox="1"/>
-          <p:nvPr/>
-        </p:nvSpPr>
-        <p:spPr>
-          <a:xfrm>
             <a:off x="540000" y="5148000"/>
             <a:ext cx="9000000" cy="360000"/>
           </a:xfrm>
@@ -12718,7 +11917,7 @@
       </p:grpSpPr>
       <p:sp>
         <p:nvSpPr>
-          <p:cNvPr id="63" name=""/>
+          <p:cNvPr id="59" name=""/>
           <p:cNvSpPr txBox="1"/>
           <p:nvPr/>
         </p:nvSpPr>
@@ -12764,7 +11963,7 @@
       </p:sp>
       <p:sp>
         <p:nvSpPr>
-          <p:cNvPr id="64" name=""/>
+          <p:cNvPr id="60" name=""/>
           <p:cNvSpPr txBox="1"/>
           <p:nvPr/>
         </p:nvSpPr>
@@ -12801,7 +12000,7 @@
       </p:sp>
       <p:pic>
         <p:nvPicPr>
-          <p:cNvPr id="65" name=""/>
+          <p:cNvPr id="61" name=""/>
           <p:cNvPicPr/>
           <p:nvPr/>
         </p:nvPicPr>
@@ -12825,96 +12024,7 @@
       </p:pic>
       <p:sp>
         <p:nvSpPr>
-          <p:cNvPr id="66" name=""/>
-          <p:cNvSpPr txBox="1"/>
-          <p:nvPr/>
-        </p:nvSpPr>
-        <p:spPr>
-          <a:xfrm>
-            <a:off x="6459120" y="2298240"/>
-            <a:ext cx="1483920" cy="362880"/>
-          </a:xfrm>
-          <a:prstGeom prst="rect">
-            <a:avLst/>
-          </a:prstGeom>
-          <a:noFill/>
-          <a:ln w="28800">
-            <a:solidFill>
-              <a:srgbClr val="D97706"/>
-            </a:solidFill>
-            <a:round/>
-          </a:ln>
-        </p:spPr>
-        <p:txBody>
-          <a:bodyPr lIns="104400" tIns="59400" rIns="104400" bIns="59400" anchor="t">
-            <a:spAutoFit/>
-          </a:bodyPr>
-          <a:p>
-            <a:endParaRPr lang="en-US" sz="1800" b="0" u="none" strike="noStrike">
-              <a:solidFill>
-                <a:srgbClr val="000000"/>
-              </a:solidFill>
-              <a:effectLst/>
-              <a:uFillTx/>
-              <a:latin typeface="Arial"/>
-            </a:endParaRPr>
-          </a:p>
-        </p:txBody>
-      </p:sp>
-      <p:sp>
-        <p:nvSpPr>
-          <p:cNvPr id="67" name=""/>
-          <p:cNvSpPr txBox="1"/>
-          <p:nvPr/>
-        </p:nvSpPr>
-        <p:spPr>
-          <a:xfrm>
-            <a:off x="6459120" y="2075040"/>
-            <a:ext cx="1994400" cy="201600"/>
-          </a:xfrm>
-          <a:prstGeom prst="rect">
-            <a:avLst/>
-          </a:prstGeom>
-          <a:solidFill>
-            <a:srgbClr val="103E3A"/>
-          </a:solidFill>
-          <a:ln w="14400">
-            <a:solidFill>
-              <a:srgbClr val="E6BF71"/>
-            </a:solidFill>
-            <a:round/>
-          </a:ln>
-        </p:spPr>
-        <p:txBody>
-          <a:bodyPr lIns="79200" tIns="28800" rIns="79200" bIns="28800" anchor="t">
-            <a:spAutoFit/>
-          </a:bodyPr>
-          <a:p>
-            <a:r>
-              <a:rPr lang="en-US" sz="950" b="1" u="none" strike="noStrike">
-                <a:solidFill>
-                  <a:srgbClr val="FFFFFF"/>
-                </a:solidFill>
-                <a:effectLst/>
-                <a:uFillTx/>
-                <a:latin typeface="Arial"/>
-              </a:rPr>
-              <a:t>Filters + Only-mine toggle</a:t>
-            </a:r>
-            <a:endParaRPr lang="en-US" sz="950" b="0" u="none" strike="noStrike">
-              <a:solidFill>
-                <a:srgbClr val="FFFFFF"/>
-              </a:solidFill>
-              <a:effectLst/>
-              <a:uFillTx/>
-              <a:latin typeface="Arial"/>
-            </a:endParaRPr>
-          </a:p>
-        </p:txBody>
-      </p:sp>
-      <p:sp>
-        <p:nvSpPr>
-          <p:cNvPr id="68" name=""/>
+          <p:cNvPr id="62" name=""/>
           <p:cNvSpPr txBox="1"/>
           <p:nvPr/>
         </p:nvSpPr>
@@ -12997,7 +12107,7 @@
       </p:grpSpPr>
       <p:sp>
         <p:nvSpPr>
-          <p:cNvPr id="69" name=""/>
+          <p:cNvPr id="63" name=""/>
           <p:cNvSpPr txBox="1"/>
           <p:nvPr/>
         </p:nvSpPr>
@@ -13043,7 +12153,7 @@
       </p:sp>
       <p:sp>
         <p:nvSpPr>
-          <p:cNvPr id="70" name=""/>
+          <p:cNvPr id="64" name=""/>
           <p:cNvSpPr txBox="1"/>
           <p:nvPr/>
         </p:nvSpPr>
@@ -13080,7 +12190,7 @@
       </p:sp>
       <p:pic>
         <p:nvPicPr>
-          <p:cNvPr id="71" name=""/>
+          <p:cNvPr id="65" name=""/>
           <p:cNvPicPr/>
           <p:nvPr/>
         </p:nvPicPr>
@@ -13104,7 +12214,7 @@
       </p:pic>
       <p:sp>
         <p:nvSpPr>
-          <p:cNvPr id="72" name=""/>
+          <p:cNvPr id="66" name=""/>
           <p:cNvSpPr txBox="1"/>
           <p:nvPr/>
         </p:nvSpPr>
@@ -13187,7 +12297,7 @@
       </p:grpSpPr>
       <p:sp>
         <p:nvSpPr>
-          <p:cNvPr id="73" name=""/>
+          <p:cNvPr id="67" name=""/>
           <p:cNvSpPr txBox="1"/>
           <p:nvPr/>
         </p:nvSpPr>
@@ -13233,7 +12343,7 @@
       </p:sp>
       <p:sp>
         <p:nvSpPr>
-          <p:cNvPr id="74" name=""/>
+          <p:cNvPr id="68" name=""/>
           <p:cNvSpPr txBox="1"/>
           <p:nvPr/>
         </p:nvSpPr>
@@ -13270,7 +12380,7 @@
       </p:sp>
       <p:pic>
         <p:nvPicPr>
-          <p:cNvPr id="75" name=""/>
+          <p:cNvPr id="69" name=""/>
           <p:cNvPicPr/>
           <p:nvPr/>
         </p:nvPicPr>
@@ -13294,185 +12404,7 @@
       </p:pic>
       <p:sp>
         <p:nvSpPr>
-          <p:cNvPr id="76" name=""/>
-          <p:cNvSpPr txBox="1"/>
-          <p:nvPr/>
-        </p:nvSpPr>
-        <p:spPr>
-          <a:xfrm>
-            <a:off x="5168880" y="2580480"/>
-            <a:ext cx="2580480" cy="1128960"/>
-          </a:xfrm>
-          <a:prstGeom prst="rect">
-            <a:avLst/>
-          </a:prstGeom>
-          <a:noFill/>
-          <a:ln w="28800">
-            <a:solidFill>
-              <a:srgbClr val="D97706"/>
-            </a:solidFill>
-            <a:round/>
-          </a:ln>
-        </p:spPr>
-        <p:txBody>
-          <a:bodyPr lIns="104400" tIns="59400" rIns="104400" bIns="59400" anchor="t">
-            <a:spAutoFit/>
-          </a:bodyPr>
-          <a:p>
-            <a:endParaRPr lang="en-US" sz="1800" b="0" u="none" strike="noStrike">
-              <a:solidFill>
-                <a:srgbClr val="000000"/>
-              </a:solidFill>
-              <a:effectLst/>
-              <a:uFillTx/>
-              <a:latin typeface="Arial"/>
-            </a:endParaRPr>
-          </a:p>
-        </p:txBody>
-      </p:sp>
-      <p:sp>
-        <p:nvSpPr>
-          <p:cNvPr id="77" name=""/>
-          <p:cNvSpPr txBox="1"/>
-          <p:nvPr/>
-        </p:nvSpPr>
-        <p:spPr>
-          <a:xfrm>
-            <a:off x="5168880" y="2357280"/>
-            <a:ext cx="2815200" cy="201600"/>
-          </a:xfrm>
-          <a:prstGeom prst="rect">
-            <a:avLst/>
-          </a:prstGeom>
-          <a:solidFill>
-            <a:srgbClr val="103E3A"/>
-          </a:solidFill>
-          <a:ln w="14400">
-            <a:solidFill>
-              <a:srgbClr val="E6BF71"/>
-            </a:solidFill>
-            <a:round/>
-          </a:ln>
-        </p:spPr>
-        <p:txBody>
-          <a:bodyPr lIns="79200" tIns="28800" rIns="79200" bIns="28800" anchor="t">
-            <a:spAutoFit/>
-          </a:bodyPr>
-          <a:p>
-            <a:r>
-              <a:rPr lang="en-US" sz="950" b="1" u="none" strike="noStrike">
-                <a:solidFill>
-                  <a:srgbClr val="FFFFFF"/>
-                </a:solidFill>
-                <a:effectLst/>
-                <a:uFillTx/>
-                <a:latin typeface="Arial"/>
-              </a:rPr>
-              <a:t>Unit · dates · item · allocation flags</a:t>
-            </a:r>
-            <a:endParaRPr lang="en-US" sz="950" b="0" u="none" strike="noStrike">
-              <a:solidFill>
-                <a:srgbClr val="FFFFFF"/>
-              </a:solidFill>
-              <a:effectLst/>
-              <a:uFillTx/>
-              <a:latin typeface="Arial"/>
-            </a:endParaRPr>
-          </a:p>
-        </p:txBody>
-      </p:sp>
-      <p:sp>
-        <p:nvSpPr>
-          <p:cNvPr id="78" name=""/>
-          <p:cNvSpPr txBox="1"/>
-          <p:nvPr/>
-        </p:nvSpPr>
-        <p:spPr>
-          <a:xfrm>
-            <a:off x="3685320" y="4314240"/>
-            <a:ext cx="2451600" cy="443520"/>
-          </a:xfrm>
-          <a:prstGeom prst="rect">
-            <a:avLst/>
-          </a:prstGeom>
-          <a:noFill/>
-          <a:ln w="28800">
-            <a:solidFill>
-              <a:srgbClr val="D97706"/>
-            </a:solidFill>
-            <a:round/>
-          </a:ln>
-        </p:spPr>
-        <p:txBody>
-          <a:bodyPr lIns="104400" tIns="59400" rIns="104400" bIns="59400" anchor="t">
-            <a:spAutoFit/>
-          </a:bodyPr>
-          <a:p>
-            <a:endParaRPr lang="en-US" sz="1800" b="0" u="none" strike="noStrike">
-              <a:solidFill>
-                <a:srgbClr val="000000"/>
-              </a:solidFill>
-              <a:effectLst/>
-              <a:uFillTx/>
-              <a:latin typeface="Arial"/>
-            </a:endParaRPr>
-          </a:p>
-        </p:txBody>
-      </p:sp>
-      <p:sp>
-        <p:nvSpPr>
-          <p:cNvPr id="79" name=""/>
-          <p:cNvSpPr txBox="1"/>
-          <p:nvPr/>
-        </p:nvSpPr>
-        <p:spPr>
-          <a:xfrm>
-            <a:off x="3685320" y="4091040"/>
-            <a:ext cx="2404800" cy="201600"/>
-          </a:xfrm>
-          <a:prstGeom prst="rect">
-            <a:avLst/>
-          </a:prstGeom>
-          <a:solidFill>
-            <a:srgbClr val="103E3A"/>
-          </a:solidFill>
-          <a:ln w="14400">
-            <a:solidFill>
-              <a:srgbClr val="E6BF71"/>
-            </a:solidFill>
-            <a:round/>
-          </a:ln>
-        </p:spPr>
-        <p:txBody>
-          <a:bodyPr lIns="79200" tIns="28800" rIns="79200" bIns="28800" anchor="t">
-            <a:spAutoFit/>
-          </a:bodyPr>
-          <a:p>
-            <a:r>
-              <a:rPr lang="en-US" sz="950" b="1" u="none" strike="noStrike">
-                <a:solidFill>
-                  <a:srgbClr val="FFFFFF"/>
-                </a:solidFill>
-                <a:effectLst/>
-                <a:uFillTx/>
-                <a:latin typeface="Arial"/>
-              </a:rPr>
-              <a:t>Multi-stage cycle: Manager -&gt; HR</a:t>
-            </a:r>
-            <a:endParaRPr lang="en-US" sz="950" b="0" u="none" strike="noStrike">
-              <a:solidFill>
-                <a:srgbClr val="FFFFFF"/>
-              </a:solidFill>
-              <a:effectLst/>
-              <a:uFillTx/>
-              <a:latin typeface="Arial"/>
-            </a:endParaRPr>
-          </a:p>
-        </p:txBody>
-      </p:sp>
-      <p:sp>
-        <p:nvSpPr>
-          <p:cNvPr id="80" name=""/>
+          <p:cNvPr id="70" name=""/>
           <p:cNvSpPr txBox="1"/>
           <p:nvPr/>
         </p:nvSpPr>

</xml_diff>